<commit_message>
docs(team): 5분 대기조 4인 매핑 확정 (placeholder → 실명)
- 박진영(@zln02) PM/Tech Lead — pipeline·ml·docs·아키텍처
- 박진(@Parkjin0821) Backend — backend/
- 윤재영(@dsadsa2311245) Frontend — frontend/
- 정욱현(@ughyeon123-source) DevOps/QA — infra·.github·tests·migrations

반영 파일:
- README.md 팀 표 추가
- .github/CODEOWNERS 모듈별 분기 (자동 리뷰 요청)
- docs/dev/Master_Dev_Guide.pdf v1.1 (BX-1~4, BE, FE, Pipe placeholder 일괄 치환)
- docs/roles/Role_*.pptx 5종 표지에 담당자 명시

Co-Authored-By: Claude Opus 4.7 <noreply@anthropic.com>
</commit_message>
<xml_diff>
--- a/docs/roles/Role_Backend.pptx
+++ b/docs/roles/Role_Backend.pptx
@@ -3295,8 +3295,8 @@
         </p:nvSpPr>
         <p:spPr>
           <a:xfrm>
-            <a:off x="548640" y="5943600"/>
-            <a:ext cx="10972800" cy="365760"/>
+            <a:off x="548640" y="3931920"/>
+            <a:ext cx="10972800" cy="548640"/>
           </a:xfrm>
           <a:prstGeom prst="rect">
             <a:avLst/>
@@ -3311,13 +3311,48 @@
           <a:p>
             <a:pPr algn="l"/>
             <a:r>
+              <a:rPr sz="1800" b="1">
+                <a:solidFill>
+                  <a:srgbClr val="FFFFFF"/>
+                </a:solidFill>
+                <a:latin typeface="나눔스퀘어라운드"/>
+              </a:rPr>
+              <a:t>담당  박진 (Parkjin0821)</a:t>
+            </a:r>
+          </a:p>
+        </p:txBody>
+      </p:sp>
+      <p:sp>
+        <p:nvSpPr>
+          <p:cNvPr id="8" name="TextBox 7"/>
+          <p:cNvSpPr txBox="1"/>
+          <p:nvPr/>
+        </p:nvSpPr>
+        <p:spPr>
+          <a:xfrm>
+            <a:off x="548640" y="5943600"/>
+            <a:ext cx="10972800" cy="365760"/>
+          </a:xfrm>
+          <a:prstGeom prst="rect">
+            <a:avLst/>
+          </a:prstGeom>
+          <a:noFill/>
+        </p:spPr>
+        <p:txBody>
+          <a:bodyPr wrap="square" lIns="73152" rIns="73152" tIns="36576" bIns="36576" anchor="t">
+            <a:spAutoFit/>
+          </a:bodyPr>
+          <a:lstStyle/>
+          <a:p>
+            <a:pPr algn="l"/>
+            <a:r>
               <a:rPr sz="1100" b="0">
                 <a:solidFill>
                   <a:srgbClr val="94A3B8"/>
                 </a:solidFill>
                 <a:latin typeface="나눔스퀘어라운드"/>
               </a:rPr>
-              <a:t>2026-06-02 · LG DX School 5기 · 5분 대기조 · v1.0</a:t>
+              <a:t>2026-06-02 · LG DX School 5기 · 5분 대기조 · v1.1</a:t>
             </a:r>
           </a:p>
         </p:txBody>

</xml_diff>